<commit_message>
Add a spoken script for the presentation, in the notes pane and as a handout
The earlier notes described what to cover; these are the words to say. They
are written for speaking aloud in a second language: short sentences, one
idea per line, ordinary vocabulary, and line breaks placed where the voice
should pause. Delivery cues and pronunciation hints sit apart from the
spoken text so they are not read out by mistake.

The script totals 962 words. That is deliberately under the ten-minute slot
- at a measured pace it runs about nine and a half minutes, leaving room to
pause, walk to the diagram and answer a question without rushing. The
rubric rewards a clear, unhurried voice, which a full ten minutes of text
would make impossible.

speaker_script.py is the single source: build_presentation.py reads it for
the PowerPoint notes pane and also writes Speaker_Script.md to practise
from away from the laptop.
</commit_message>
<xml_diff>
--- a/submission/Early_Stage_Presentation_DataExodus.pptx
+++ b/submission/Early_Stage_Presentation_DataExodus.pptx
@@ -516,29 +516,31 @@
               <a:t>[0:00-0:15]</a:t>
             </a:r>
           </a:p>
-          <a:p>
-            <a:r>
-              <a:t>Good morning. My project is called DataExodus, and it answers one question:</a:t>
-            </a:r>
-          </a:p>
-          <a:p>
-            <a:r>
-              <a:t>when you open an ordinary Australian website, where does your data actually go?</a:t>
-            </a:r>
-          </a:p>
-          <a:p>
-            <a:r>
-              <a:t>Over the next ten minutes I'll cover the problem, what I'm building, how I'm</a:t>
-            </a:r>
-          </a:p>
-          <a:p>
-            <a:r>
-              <a:t>building it, and what is already working.</a:t>
-            </a:r>
-          </a:p>
-          <a:p>
-            <a:r>
-              <a:t>Do not read the slide. Say the question, then pause.</a:t>
+          <a:p/>
+          <a:p>
+            <a:r>
+              <a:t>Good morning. My name is Thanh Dat Phan.</a:t>
+            </a:r>
+          </a:p>
+          <a:p>
+            <a:r>
+              <a:t>My project is called DataExodus.</a:t>
+            </a:r>
+          </a:p>
+          <a:p>
+            <a:r>
+              <a:t>It answers one question.</a:t>
+            </a:r>
+          </a:p>
+          <a:p>
+            <a:r>
+              <a:t>When you open a normal website - where does your data go?</a:t>
+            </a:r>
+          </a:p>
+          <a:p/>
+          <a:p>
+            <a:r>
+              <a:t>[Delivery] Ask the question, then stop. Look at the audience, not the screen.</a:t>
             </a:r>
           </a:p>
         </p:txBody>
@@ -611,58 +613,76 @@
               <a:t>[8:25-9:25]</a:t>
             </a:r>
           </a:p>
-          <a:p>
-            <a:r>
-              <a:t>This is the slide I'd most like you to take away, because none of it is a plan -</a:t>
-            </a:r>
-          </a:p>
-          <a:p>
-            <a:r>
-              <a:t>it's all been run.</a:t>
-            </a:r>
-          </a:p>
           <a:p/>
           <a:p>
             <a:r>
-              <a:t>The MD5 I wrote is verified against twelve reference vectors, including the padding</a:t>
-            </a:r>
-          </a:p>
-          <a:p>
-            <a:r>
-              <a:t>boundaries at 55, 56 and 57 bytes, which is where hand-written MD5 usually breaks.</a:t>
+              <a:t>This is the most important slide.</a:t>
+            </a:r>
+          </a:p>
+          <a:p>
+            <a:r>
+              <a:t>None of this is a plan. I have run all of it.</a:t>
+            </a:r>
+          </a:p>
+          <a:p>
+            <a:r>
+              <a:t>My MD5 code is tested against twelve known answers.</a:t>
+            </a:r>
+          </a:p>
+          <a:p>
+            <a:r>
+              <a:t>That includes the sizes where hand-written MD5 usually breaks.</a:t>
+            </a:r>
+          </a:p>
+          <a:p>
+            <a:r>
+              <a:t>Now the best example.</a:t>
+            </a:r>
+          </a:p>
+          <a:p>
+            <a:r>
+              <a:t>You type your phone number with spaces.</a:t>
+            </a:r>
+          </a:p>
+          <a:p>
+            <a:r>
+              <a:t>The tracker removes the spaces and adds the country code.</a:t>
+            </a:r>
+          </a:p>
+          <a:p>
+            <a:r>
+              <a:t>Then it hashes that.</a:t>
+            </a:r>
+          </a:p>
+          <a:p>
+            <a:r>
+              <a:t>My old code matched nothing. It reported no leak. Silently.</a:t>
+            </a:r>
+          </a:p>
+          <a:p>
+            <a:r>
+              <a:t>My new code hashes every form.</a:t>
+            </a:r>
+          </a:p>
+          <a:p>
+            <a:r>
+              <a:t>I have a test that proves the old one missed, and the new one matches.</a:t>
+            </a:r>
+          </a:p>
+          <a:p>
+            <a:r>
+              <a:t>And zero false positives on blocking.</a:t>
+            </a:r>
+          </a:p>
+          <a:p>
+            <a:r>
+              <a:t>That is goal four, already met.</a:t>
             </a:r>
           </a:p>
           <a:p/>
           <a:p>
             <a:r>
-              <a:t>The normalisation line is my favourite. If you type your phone number as "0412 345</a:t>
-            </a:r>
-          </a:p>
-          <a:p>
-            <a:r>
-              <a:t>678" and a tracker hashes "61412345678", the old version of my code matched nothing</a:t>
-            </a:r>
-          </a:p>
-          <a:p>
-            <a:r>
-              <a:t>and reported no leak - silently. The fix hashes every plausible form. I have a test</a:t>
-            </a:r>
-          </a:p>
-          <a:p>
-            <a:r>
-              <a:t>that proves the old one missed and the new one matches.</a:t>
-            </a:r>
-          </a:p>
-          <a:p/>
-          <a:p>
-            <a:r>
-              <a:t>And zero false positives on the DNS blocking, which is the G4 number.</a:t>
-            </a:r>
-          </a:p>
-          <a:p/>
-          <a:p>
-            <a:r>
-              <a:t>Say "none of this is a plan, it's all been run" and then pause.</a:t>
+              <a:t>[Delivery] Pause after 'I have run all of it'. This slide answers 'is this student actually doing the work'.</a:t>
             </a:r>
           </a:p>
         </p:txBody>
@@ -735,41 +755,61 @@
               <a:t>[9:25-9:55]</a:t>
             </a:r>
           </a:p>
-          <a:p>
-            <a:r>
-              <a:t>Briefly: weeks 9 and 10 are the full crawl, 11 is deployment and the false-positive</a:t>
-            </a:r>
-          </a:p>
-          <a:p>
-            <a:r>
-              <a:t>testing, 12 and 13 are the dashboard and the analysis, 14 is the final presentation.</a:t>
-            </a:r>
-          </a:p>
           <a:p/>
           <a:p>
             <a:r>
-              <a:t>On risk - the honest one is the third. If someone turns on Chrome's secure DNS,</a:t>
-            </a:r>
-          </a:p>
-          <a:p>
-            <a:r>
-              <a:t>their queries go straight to Google and my sinkhole never sees them. I can't stop</a:t>
-            </a:r>
-          </a:p>
-          <a:p>
-            <a:r>
-              <a:t>that. But the extension still observes those requests, which is precisely why the</a:t>
-            </a:r>
-          </a:p>
-          <a:p>
-            <a:r>
-              <a:t>project is two deliverables and not one.</a:t>
+              <a:t>Week nine and ten: the full crawl of fifty sites.</a:t>
+            </a:r>
+          </a:p>
+          <a:p>
+            <a:r>
+              <a:t>Week eleven: deployment and false positive testing.</a:t>
+            </a:r>
+          </a:p>
+          <a:p>
+            <a:r>
+              <a:t>Week twelve and thirteen: dashboard and analysis.</a:t>
+            </a:r>
+          </a:p>
+          <a:p>
+            <a:r>
+              <a:t>Week fourteen: the final presentation.</a:t>
+            </a:r>
+          </a:p>
+          <a:p>
+            <a:r>
+              <a:t>Now one honest risk. The third one.</a:t>
+            </a:r>
+          </a:p>
+          <a:p>
+            <a:r>
+              <a:t>Chrome has a setting called secure DNS.</a:t>
+            </a:r>
+          </a:p>
+          <a:p>
+            <a:r>
+              <a:t>If someone turns it on, my Pi never sees their questions.</a:t>
+            </a:r>
+          </a:p>
+          <a:p>
+            <a:r>
+              <a:t>I cannot stop that.</a:t>
+            </a:r>
+          </a:p>
+          <a:p>
+            <a:r>
+              <a:t>But the extension still sees those requests.</a:t>
+            </a:r>
+          </a:p>
+          <a:p>
+            <a:r>
+              <a:t>That is exactly why this project has two parts, not one.</a:t>
             </a:r>
           </a:p>
           <a:p/>
           <a:p>
             <a:r>
-              <a:t>Don't rush this slide just because it's near the end.</a:t>
+              <a:t>[Delivery] Do not rush because you are near the end. The risk slide shows you understand your own limits.</a:t>
             </a:r>
           </a:p>
         </p:txBody>
@@ -842,66 +882,82 @@
               <a:t>[9:55-10:00]</a:t>
             </a:r>
           </a:p>
-          <a:p>
-            <a:r>
-              <a:t>To close: a hash is not anonymous, and this project proves it on your own traffic</a:t>
-            </a:r>
-          </a:p>
-          <a:p>
-            <a:r>
-              <a:t>rather than describing it. The extension shows you the problem; the Pi does</a:t>
-            </a:r>
-          </a:p>
-          <a:p>
-            <a:r>
-              <a:t>something about it for every device you own.</a:t>
-            </a:r>
-          </a:p>
           <a:p/>
           <a:p>
             <a:r>
-              <a:t>Happy to take questions.</a:t>
+              <a:t>So. A hash is not anonymous.</a:t>
+            </a:r>
+          </a:p>
+          <a:p>
+            <a:r>
+              <a:t>This project proves it on your own traffic. Then it blocks it.</a:t>
+            </a:r>
+          </a:p>
+          <a:p>
+            <a:r>
+              <a:t>Thank you. I am happy to take questions.</a:t>
             </a:r>
           </a:p>
           <a:p/>
           <a:p>
             <a:r>
-              <a:t>Likely questions and short answers:</a:t>
-            </a:r>
-          </a:p>
-          <a:p>
-            <a:r>
-              <a:t>- "Why not just use Pi-hole?" Pi-hole blocks. It doesn't tell you who owns a</a:t>
-            </a:r>
-          </a:p>
-          <a:p>
-            <a:r>
-              <a:t>  destination, which country it's in, or whether your identifier went with it.</a:t>
-            </a:r>
-          </a:p>
-          <a:p>
-            <a:r>
-              <a:t>- "Is this legal?" Public pages only, my own traffic, my own identifier, no logins</a:t>
-            </a:r>
-          </a:p>
-          <a:p>
-            <a:r>
-              <a:t>  and no attacks - the same basis as published academic measurement work.</a:t>
-            </a:r>
-          </a:p>
-          <a:p>
-            <a:r>
-              <a:t>- "Why only 50 sites?" Because I verify every classification by hand. Fifty is a</a:t>
-            </a:r>
-          </a:p>
-          <a:p>
-            <a:r>
-              <a:t>  number I can audit; five thousand is a number I could only assert.</a:t>
-            </a:r>
-          </a:p>
-          <a:p>
-            <a:r>
-              <a:t>- "What if you find nothing?" I report that. It's a measurement, not an argument.</a:t>
+              <a:t>[Delivery] Stand still. Do not fill the silence. Wait for the first question.</a:t>
+            </a:r>
+          </a:p>
+          <a:p/>
+          <a:p>
+            <a:r>
+              <a:t>[Likely questions]</a:t>
+            </a:r>
+          </a:p>
+          <a:p>
+            <a:r>
+              <a:t>Q: Why not just use Pi-hole?</a:t>
+            </a:r>
+          </a:p>
+          <a:p>
+            <a:r>
+              <a:t>A: Pi-hole blocks. It does not tell you who owns the destination, which country it is in, or whether your identifier went with it.</a:t>
+            </a:r>
+          </a:p>
+          <a:p>
+            <a:r>
+              <a:t>Q: Is this legal?</a:t>
+            </a:r>
+          </a:p>
+          <a:p>
+            <a:r>
+              <a:t>A: Public pages only. My own traffic. My own identifier. No logins, no attacks. The same basis as published academic studies.</a:t>
+            </a:r>
+          </a:p>
+          <a:p>
+            <a:r>
+              <a:t>Q: Why only fifty sites?</a:t>
+            </a:r>
+          </a:p>
+          <a:p>
+            <a:r>
+              <a:t>A: Because I check every classification by hand. Fifty is a number I can verify. Five thousand is a number I could only claim.</a:t>
+            </a:r>
+          </a:p>
+          <a:p>
+            <a:r>
+              <a:t>Q: What if you find nothing?</a:t>
+            </a:r>
+          </a:p>
+          <a:p>
+            <a:r>
+              <a:t>A: Then I report that. It is a measurement, not an argument.</a:t>
+            </a:r>
+          </a:p>
+          <a:p>
+            <a:r>
+              <a:t>Q: How do you know your blocking is safe?</a:t>
+            </a:r>
+          </a:p>
+          <a:p>
+            <a:r>
+              <a:t>A: I test it against a fixed list of twelve normal websites before deployment. Zero false positives is the pass condition, and I can roll the DNS setting back.</a:t>
             </a:r>
           </a:p>
         </p:txBody>
@@ -974,47 +1030,71 @@
               <a:t>[0:15-1:25]</a:t>
             </a:r>
           </a:p>
-          <a:p>
-            <a:r>
-              <a:t>This is the heart of the project. A tracker rarely sends your email address in</a:t>
-            </a:r>
-          </a:p>
-          <a:p>
-            <a:r>
-              <a:t>plain text - it sends the hash of it, and calls that anonymised.</a:t>
-            </a:r>
-          </a:p>
           <a:p/>
           <a:p>
             <a:r>
-              <a:t>But hashing is deterministic. The same email always produces the same hash. So</a:t>
-            </a:r>
-          </a:p>
-          <a:p>
-            <a:r>
-              <a:t>that value is still a name for you, it just isn't readable. Any site that</a:t>
-            </a:r>
-          </a:p>
-          <a:p>
-            <a:r>
-              <a:t>receives it recognises the same person.</a:t>
+              <a:t>Here is the problem.</a:t>
+            </a:r>
+          </a:p>
+          <a:p>
+            <a:r>
+              <a:t>A tracker does not send your email address.</a:t>
+            </a:r>
+          </a:p>
+          <a:p>
+            <a:r>
+              <a:t>It sends a hash of it. This number here.</a:t>
+            </a:r>
+          </a:p>
+          <a:p>
+            <a:r>
+              <a:t>And the company calls that anonymous.</a:t>
+            </a:r>
+          </a:p>
+          <a:p>
+            <a:r>
+              <a:t>It is not anonymous.</a:t>
+            </a:r>
+          </a:p>
+          <a:p>
+            <a:r>
+              <a:t>Here is why.</a:t>
+            </a:r>
+          </a:p>
+          <a:p>
+            <a:r>
+              <a:t>The same email always makes the same hash. Always.</a:t>
+            </a:r>
+          </a:p>
+          <a:p>
+            <a:r>
+              <a:t>So this number is still your name. You just cannot read it.</a:t>
+            </a:r>
+          </a:p>
+          <a:p>
+            <a:r>
+              <a:t>Every website that receives this number sees the same person.</a:t>
+            </a:r>
+          </a:p>
+          <a:p>
+            <a:r>
+              <a:t>The US Federal Trade Commission said this in 2024.</a:t>
+            </a:r>
+          </a:p>
+          <a:p>
+            <a:r>
+              <a:t>My project does not only explain this.</a:t>
+            </a:r>
+          </a:p>
+          <a:p>
+            <a:r>
+              <a:t>It proves it, on your own traffic.</a:t>
             </a:r>
           </a:p>
           <a:p/>
           <a:p>
             <a:r>
-              <a:t>The FTC said exactly this in 2024. My project doesn't argue the point - it</a:t>
-            </a:r>
-          </a:p>
-          <a:p>
-            <a:r>
-              <a:t>demonstrates it, on the audience's own traffic.</a:t>
-            </a:r>
-          </a:p>
-          <a:p/>
-          <a:p>
-            <a:r>
-              <a:t>Pause after "It is not." Let it land.</a:t>
+              <a:t>[Delivery] Say 'It is not anonymous' slowly, then pause two seconds. anonymous = uh-NON-uh-muss.</a:t>
             </a:r>
           </a:p>
         </p:txBody>
@@ -1087,41 +1167,56 @@
               <a:t>[1:25-2:25]</a:t>
             </a:r>
           </a:p>
-          <a:p>
-            <a:r>
-              <a:t>Why Australia specifically. Australian Privacy Principle 8 places obligations on</a:t>
-            </a:r>
-          </a:p>
-          <a:p>
-            <a:r>
-              <a:t>organisations that send personal information overseas. The ACCC's Digital</a:t>
-            </a:r>
-          </a:p>
-          <a:p>
-            <a:r>
-              <a:t>Platforms Inquiry found consumers have almost no practical visibility of this.</a:t>
-            </a:r>
-          </a:p>
           <a:p/>
           <a:p>
             <a:r>
-              <a:t>So there is a law about cross-border disclosure, and no way for an ordinary</a:t>
-            </a:r>
-          </a:p>
-          <a:p>
-            <a:r>
-              <a:t>person to see whether it is happening to them. That gap is what I'm building for.</a:t>
+              <a:t>Why does this matter here in Australia?</a:t>
+            </a:r>
+          </a:p>
+          <a:p>
+            <a:r>
+              <a:t>We have a law. The Privacy Act. Principle 8.</a:t>
+            </a:r>
+          </a:p>
+          <a:p>
+            <a:r>
+              <a:t>If a company sends your data overseas, it has duties.</a:t>
+            </a:r>
+          </a:p>
+          <a:p>
+            <a:r>
+              <a:t>The ACCC studied this problem.</a:t>
+            </a:r>
+          </a:p>
+          <a:p>
+            <a:r>
+              <a:t>They found that people cannot see who receives their data.</a:t>
+            </a:r>
+          </a:p>
+          <a:p>
+            <a:r>
+              <a:t>So we have a law about it.</a:t>
+            </a:r>
+          </a:p>
+          <a:p>
+            <a:r>
+              <a:t>But a normal person cannot check it.</a:t>
+            </a:r>
+          </a:p>
+          <a:p>
+            <a:r>
+              <a:t>That gap is what I am building for.</a:t>
+            </a:r>
+          </a:p>
+          <a:p>
+            <a:r>
+              <a:t>This is my own project. I have no client.</a:t>
             </a:r>
           </a:p>
           <a:p/>
           <a:p>
             <a:r>
-              <a:t>This is my own initiative - there's no external client. The assessor is the</a:t>
-            </a:r>
-          </a:p>
-          <a:p>
-            <a:r>
-              <a:t>approving stakeholder.</a:t>
+              <a:t>[Delivery] Slow down on 'Principle 8'. Let the contrast land: there is a law, but no way to check it.</a:t>
             </a:r>
           </a:p>
         </p:txBody>
@@ -1194,57 +1289,71 @@
               <a:t>[2:25-3:25]</a:t>
             </a:r>
           </a:p>
-          <a:p>
-            <a:r>
-              <a:t>The project is two things a person actually installs.</a:t>
-            </a:r>
-          </a:p>
           <a:p/>
           <a:p>
             <a:r>
-              <a:t>First, a Chrome extension. It watches every request the browser makes, names the</a:t>
-            </a:r>
-          </a:p>
-          <a:p>
-            <a:r>
-              <a:t>company behind each destination, scores the page for risk, and detects your own</a:t>
-            </a:r>
-          </a:p>
-          <a:p>
-            <a:r>
-              <a:t>identifier leaving as a hash.</a:t>
+              <a:t>I am building two things. You can install both.</a:t>
+            </a:r>
+          </a:p>
+          <a:p>
+            <a:r>
+              <a:t>First, a Chrome extension.</a:t>
+            </a:r>
+          </a:p>
+          <a:p>
+            <a:r>
+              <a:t>It watches every request your browser makes.</a:t>
+            </a:r>
+          </a:p>
+          <a:p>
+            <a:r>
+              <a:t>It names the company. It scores the risk.</a:t>
+            </a:r>
+          </a:p>
+          <a:p>
+            <a:r>
+              <a:t>And it watches for your identifier leaving.</a:t>
+            </a:r>
+          </a:p>
+          <a:p>
+            <a:r>
+              <a:t>Second, a Raspberry Pi application.</a:t>
+            </a:r>
+          </a:p>
+          <a:p>
+            <a:r>
+              <a:t>It adds the country. It keeps the history.</a:t>
+            </a:r>
+          </a:p>
+          <a:p>
+            <a:r>
+              <a:t>And it blocks trackers using DNS.</a:t>
+            </a:r>
+          </a:p>
+          <a:p>
+            <a:r>
+              <a:t>DNS covers every device. Your phone. Your television.</a:t>
+            </a:r>
+          </a:p>
+          <a:p>
+            <a:r>
+              <a:t>Those can never run an extension.</a:t>
+            </a:r>
+          </a:p>
+          <a:p>
+            <a:r>
+              <a:t>One sentence to remember.</a:t>
+            </a:r>
+          </a:p>
+          <a:p>
+            <a:r>
+              <a:t>The extension shows you the problem. The Pi does something about it.</a:t>
             </a:r>
           </a:p>
           <a:p/>
           <a:p>
             <a:r>
-              <a:t>Second, a Raspberry Pi application. It collects what the extension sees, adds</a:t>
-            </a:r>
-          </a:p>
-          <a:p>
-            <a:r>
-              <a:t>country attribution the browser can't do, and blocks tracker domains by DNS -</a:t>
-            </a:r>
-          </a:p>
-          <a:p>
-            <a:r>
-              <a:t>which covers every device on the network, including the phone and the TV that</a:t>
-            </a:r>
-          </a:p>
-          <a:p>
-            <a:r>
-              <a:t>can never run an extension.</a:t>
-            </a:r>
-          </a:p>
-          <a:p/>
-          <a:p>
-            <a:r>
-              <a:t>One line to remember: the extension shows you the problem, the Pi does something</a:t>
-            </a:r>
-          </a:p>
-          <a:p>
-            <a:r>
-              <a:t>about it.</a:t>
+              <a:t>[Delivery] Point left for the extension, right for the Pi. Say the last two sentences slowly - this is the line they remember.</a:t>
             </a:r>
           </a:p>
         </p:txBody>
@@ -1317,57 +1426,76 @@
               <a:t>[3:25-4:40]</a:t>
             </a:r>
           </a:p>
+          <a:p/>
           <a:p>
             <a:r>
               <a:t>This is the whole system on one slide.</a:t>
             </a:r>
           </a:p>
+          <a:p>
+            <a:r>
+              <a:t>On the left is your home.</a:t>
+            </a:r>
+          </a:p>
+          <a:p>
+            <a:r>
+              <a:t>The laptop runs the extension. The phone and the TV cannot.</a:t>
+            </a:r>
+          </a:p>
+          <a:p>
+            <a:r>
+              <a:t>In the middle is the Raspberry Pi.</a:t>
+            </a:r>
+          </a:p>
+          <a:p>
+            <a:r>
+              <a:t>At the top, the DNS sinkhole. It answers tracker questions with zero.</a:t>
+            </a:r>
+          </a:p>
+          <a:p>
+            <a:r>
+              <a:t>Below that, the app. It receives the data and stores it.</a:t>
+            </a:r>
+          </a:p>
+          <a:p>
+            <a:r>
+              <a:t>At the bottom, the dashboard.</a:t>
+            </a:r>
+          </a:p>
+          <a:p>
+            <a:r>
+              <a:t>Now look at the orange bar.</a:t>
+            </a:r>
+          </a:p>
+          <a:p>
+            <a:r>
+              <a:t>This is the privacy boundary.</a:t>
+            </a:r>
+          </a:p>
+          <a:p>
+            <a:r>
+              <a:t>Your real email never crosses it. Full web addresses never cross it.</a:t>
+            </a:r>
+          </a:p>
+          <a:p>
+            <a:r>
+              <a:t>Only hashes are compared. Only host names are sent.</a:t>
+            </a:r>
+          </a:p>
+          <a:p>
+            <a:r>
+              <a:t>A web address contains your search words.</a:t>
+            </a:r>
+          </a:p>
+          <a:p>
+            <a:r>
+              <a:t>This is a privacy tool. So I do not send it.</a:t>
+            </a:r>
+          </a:p>
           <a:p/>
           <a:p>
             <a:r>
-              <a:t>On the left, the home network. The laptop runs the extension; the phone and the</a:t>
-            </a:r>
-          </a:p>
-          <a:p>
-            <a:r>
-              <a:t>TV cannot. In the middle, the Raspberry Pi: the DNS sinkhole at the top answers</a:t>
-            </a:r>
-          </a:p>
-          <a:p>
-            <a:r>
-              <a:t>tracker queries with 0.0.0.0, the FastAPI app receives telemetry, classify and</a:t>
-            </a:r>
-          </a:p>
-          <a:p>
-            <a:r>
-              <a:t>store handle attribution and storage, and the dashboard presents it.</a:t>
-            </a:r>
-          </a:p>
-          <a:p/>
-          <a:p>
-            <a:r>
-              <a:t>Point at the orange bar along the bottom. That is the privacy boundary. The raw</a:t>
-            </a:r>
-          </a:p>
-          <a:p>
-            <a:r>
-              <a:t>email and the full page URLs never cross it. Only hashes are compared and only</a:t>
-            </a:r>
-          </a:p>
-          <a:p>
-            <a:r>
-              <a:t>hostnames are sent - because a URL carries your search terms and session ids, and</a:t>
-            </a:r>
-          </a:p>
-          <a:p>
-            <a:r>
-              <a:t>this is supposed to be a privacy tool.</a:t>
-            </a:r>
-          </a:p>
-          <a:p/>
-          <a:p>
-            <a:r>
-              <a:t>Walk the diagram left to right with your hand, then turn back to the audience.</a:t>
+              <a:t>[Delivery] Move your hand across the diagram, left to right. Then turn back and face the audience for the orange bar.</a:t>
             </a:r>
           </a:p>
         </p:txBody>
@@ -1440,52 +1568,71 @@
               <a:t>[4:40-5:40]</a:t>
             </a:r>
           </a:p>
-          <a:p>
-            <a:r>
-              <a:t>Seven high-level requirements on the left - what the system has to do. Seven</a:t>
-            </a:r>
-          </a:p>
-          <a:p>
-            <a:r>
-              <a:t>matching implementation decisions on the right - how.</a:t>
-            </a:r>
-          </a:p>
           <a:p/>
           <a:p>
             <a:r>
-              <a:t>I'll call out two. HR-4: distinguishing covert from intentional. If you type your</a:t>
-            </a:r>
-          </a:p>
-          <a:p>
-            <a:r>
-              <a:t>email into a site's own search box, that's you choosing to. If that site quietly</a:t>
-            </a:r>
-          </a:p>
-          <a:p>
-            <a:r>
-              <a:t>forwards the hash to Facebook, that's the thing worth alarming about. Early on I</a:t>
-            </a:r>
-          </a:p>
-          <a:p>
-            <a:r>
-              <a:t>treated both the same, and everything looked like a breach.</a:t>
+              <a:t>Seven requirements on the left. What the system must do.</a:t>
+            </a:r>
+          </a:p>
+          <a:p>
+            <a:r>
+              <a:t>Seven decisions on the right. How I do it.</a:t>
+            </a:r>
+          </a:p>
+          <a:p>
+            <a:r>
+              <a:t>I will explain two of them.</a:t>
+            </a:r>
+          </a:p>
+          <a:p>
+            <a:r>
+              <a:t>Number four. Hidden sharing, versus your own choice.</a:t>
+            </a:r>
+          </a:p>
+          <a:p>
+            <a:r>
+              <a:t>You type your email into a search box. That is your choice. That is fine.</a:t>
+            </a:r>
+          </a:p>
+          <a:p>
+            <a:r>
+              <a:t>The site sends your email hash to Facebook. That is not fine.</a:t>
+            </a:r>
+          </a:p>
+          <a:p>
+            <a:r>
+              <a:t>At first my code treated both the same.</a:t>
+            </a:r>
+          </a:p>
+          <a:p>
+            <a:r>
+              <a:t>Then everything looked like a leak.</a:t>
+            </a:r>
+          </a:p>
+          <a:p>
+            <a:r>
+              <a:t>Now, normalisation.</a:t>
+            </a:r>
+          </a:p>
+          <a:p>
+            <a:r>
+              <a:t>A tracker does not hash what you typed.</a:t>
+            </a:r>
+          </a:p>
+          <a:p>
+            <a:r>
+              <a:t>It cleans the value first, then hashes it.</a:t>
+            </a:r>
+          </a:p>
+          <a:p>
+            <a:r>
+              <a:t>I will show you why that matters.</a:t>
             </a:r>
           </a:p>
           <a:p/>
           <a:p>
             <a:r>
-              <a:t>And the normalisation row. A tracker doesn't hash what you typed - it hashes what</a:t>
-            </a:r>
-          </a:p>
-          <a:p>
-            <a:r>
-              <a:t>its own pipeline normalised first. I'll come back to that.</a:t>
-            </a:r>
-          </a:p>
-          <a:p/>
-          <a:p>
-            <a:r>
-              <a:t>In the plan each of these is traced through to how it gets verified.</a:t>
+              <a:t>[Delivery] normalisation = nor-muh-lie-ZAY-shun. End with 'I will show you why' - it sets up slide ten.</a:t>
             </a:r>
           </a:p>
         </p:txBody>
@@ -1558,42 +1705,56 @@
               <a:t>[5:40-6:25]</a:t>
             </a:r>
           </a:p>
-          <a:p>
-            <a:r>
-              <a:t>Six goals, each measurable and dated, and together they cover every requirement.</a:t>
-            </a:r>
-          </a:p>
           <a:p/>
           <a:p>
             <a:r>
-              <a:t>The one I'd point at is G4: zero false positives. Not "few". At the DNS layer a</a:t>
-            </a:r>
-          </a:p>
-          <a:p>
-            <a:r>
-              <a:t>false positive doesn't inconvenience one browser - it takes a website off the air</a:t>
-            </a:r>
-          </a:p>
-          <a:p>
-            <a:r>
-              <a:t>for everyone in the house. That's the number that has to be zero.</a:t>
+              <a:t>Six goals. Each one has a number and a date.</a:t>
+            </a:r>
+          </a:p>
+          <a:p>
+            <a:r>
+              <a:t>Together they cover every requirement.</a:t>
+            </a:r>
+          </a:p>
+          <a:p>
+            <a:r>
+              <a:t>Look at goal four. Zero false positives.</a:t>
+            </a:r>
+          </a:p>
+          <a:p>
+            <a:r>
+              <a:t>Not 'a few'. Zero.</a:t>
+            </a:r>
+          </a:p>
+          <a:p>
+            <a:r>
+              <a:t>Because at the DNS layer, a mistake is not small.</a:t>
+            </a:r>
+          </a:p>
+          <a:p>
+            <a:r>
+              <a:t>It removes a website for the whole house.</a:t>
+            </a:r>
+          </a:p>
+          <a:p>
+            <a:r>
+              <a:t>And goal six says 'significant or not'.</a:t>
+            </a:r>
+          </a:p>
+          <a:p>
+            <a:r>
+              <a:t>If I find nothing, I report nothing.</a:t>
+            </a:r>
+          </a:p>
+          <a:p>
+            <a:r>
+              <a:t>This is a measurement. It is not an argument.</a:t>
             </a:r>
           </a:p>
           <a:p/>
           <a:p>
             <a:r>
-              <a:t>G6 says "significant or not" deliberately. If sectors don't differ, I report that.</a:t>
-            </a:r>
-          </a:p>
-          <a:p>
-            <a:r>
-              <a:t>I'm not designing this to confirm an answer I already like.</a:t>
-            </a:r>
-          </a:p>
-          <a:p/>
-          <a:p>
-            <a:r>
-              <a:t>Don't read all six. Name the count, then talk about G4 and G6.</a:t>
+              <a:t>[Delivery] Do not read all six goals. Name the number, then talk about goal four and goal six only.</a:t>
             </a:r>
           </a:p>
         </p:txBody>
@@ -1666,74 +1827,91 @@
               <a:t>[6:25-7:40]</a:t>
             </a:r>
           </a:p>
-          <a:p>
-            <a:r>
-              <a:t>Methodology, and this is where I want to be concrete rather than quote a textbook.</a:t>
-            </a:r>
-          </a:p>
           <a:p/>
           <a:p>
             <a:r>
-              <a:t>I build in vertical layers. Each one is a complete working system by itself, and</a:t>
-            </a:r>
-          </a:p>
-          <a:p>
-            <a:r>
-              <a:t>later layers add capability without making earlier ones worthless.</a:t>
+              <a:t>I build in layers. Each layer works on its own.</a:t>
+            </a:r>
+          </a:p>
+          <a:p>
+            <a:r>
+              <a:t>Layer one, the extension. Layer two, the Pi.</a:t>
+            </a:r>
+          </a:p>
+          <a:p>
+            <a:r>
+              <a:t>Layer three, blocking. Layer four, the study.</a:t>
+            </a:r>
+          </a:p>
+          <a:p>
+            <a:r>
+              <a:t>Why not waterfall?</a:t>
+            </a:r>
+          </a:p>
+          <a:p>
+            <a:r>
+              <a:t>My hardest questions are technical, and they come early.</a:t>
+            </a:r>
+          </a:p>
+          <a:p>
+            <a:r>
+              <a:t>Waterfall would find them at the end. Too late to fix.</a:t>
+            </a:r>
+          </a:p>
+          <a:p>
+            <a:r>
+              <a:t>Why not Scrum?</a:t>
+            </a:r>
+          </a:p>
+          <a:p>
+            <a:r>
+              <a:t>Scrum meetings organise a team. I am one person.</a:t>
+            </a:r>
+          </a:p>
+          <a:p>
+            <a:r>
+              <a:t>I kept the short steps. I dropped the meetings.</a:t>
+            </a:r>
+          </a:p>
+          <a:p>
+            <a:r>
+              <a:t>And here is proof this was the right choice.</a:t>
+            </a:r>
+          </a:p>
+          <a:p>
+            <a:r>
+              <a:t>My blocking code marked Wikipedia as a tracker. GitHub too.</a:t>
+            </a:r>
+          </a:p>
+          <a:p>
+            <a:r>
+              <a:t>Why? A filter rule that blocks one page</a:t>
+            </a:r>
+          </a:p>
+          <a:p>
+            <a:r>
+              <a:t>was read as blocking the whole website.</a:t>
+            </a:r>
+          </a:p>
+          <a:p>
+            <a:r>
+              <a:t>At the DNS layer, that removes Wikipedia.</a:t>
+            </a:r>
+          </a:p>
+          <a:p>
+            <a:r>
+              <a:t>For every device in the house.</a:t>
+            </a:r>
+          </a:p>
+          <a:p>
+            <a:r>
+              <a:t>I found it because I tested that layer alone, before connecting it.</a:t>
             </a:r>
           </a:p>
           <a:p/>
           <a:p>
             <a:r>
-              <a:t>Why not waterfall: my riskiest unknowns are technical and they sit early. Waterfall</a:t>
-            </a:r>
-          </a:p>
-          <a:p>
-            <a:r>
-              <a:t>would surface them in an integration phase with no time left to react.</a:t>
-            </a:r>
-          </a:p>
-          <a:p/>
-          <a:p>
-            <a:r>
-              <a:t>Why not formal Scrum: the ceremonies exist to coordinate a team. There's one of me.</a:t>
-            </a:r>
-          </a:p>
-          <a:p>
-            <a:r>
-              <a:t>I kept short increments and working software; I dropped the meetings.</a:t>
-            </a:r>
-          </a:p>
-          <a:p/>
-          <a:p>
-            <a:r>
-              <a:t>And here's the evidence it was the right call. My DNS blocklist parser classified</a:t>
-            </a:r>
-          </a:p>
-          <a:p>
-            <a:r>
-              <a:t>wikipedia.org and github.com as trackers - because filter rules that block a single</a:t>
-            </a:r>
-          </a:p>
-          <a:p>
-            <a:r>
-              <a:t>path were being read as blocking the whole domain. At the DNS layer that takes</a:t>
-            </a:r>
-          </a:p>
-          <a:p>
-            <a:r>
-              <a:t>Wikipedia off the air for every device in the house. I caught it because I tested</a:t>
-            </a:r>
-          </a:p>
-          <a:p>
-            <a:r>
-              <a:t>that layer in isolation before connecting it to anything.</a:t>
-            </a:r>
-          </a:p>
-          <a:p/>
-          <a:p>
-            <a:r>
-              <a:t>This story is worth telling properly - it's the strongest thing on the slide.</a:t>
+              <a:t>[Delivery] This is your strongest story. Tell it fully. Pause before 'And here is proof'.</a:t>
             </a:r>
           </a:p>
         </p:txBody>
@@ -1806,47 +1984,61 @@
               <a:t>[7:40-8:25]</a:t>
             </a:r>
           </a:p>
-          <a:p>
-            <a:r>
-              <a:t>Quickly on tools, because the plan justifies each one in detail.</a:t>
-            </a:r>
-          </a:p>
           <a:p/>
           <a:p>
             <a:r>
-              <a:t>Two worth naming here. DuckDB, because my questions are aggregate ones - "which</a:t>
-            </a:r>
-          </a:p>
-          <a:p>
-            <a:r>
-              <a:t>company receives the most requests" - and that's what a columnar database is for,</a:t>
-            </a:r>
-          </a:p>
-          <a:p>
-            <a:r>
-              <a:t>in a single file with no server to administer.</a:t>
+              <a:t>Now the tools. Quickly - the plan explains each one.</a:t>
+            </a:r>
+          </a:p>
+          <a:p>
+            <a:r>
+              <a:t>I want to name two.</a:t>
+            </a:r>
+          </a:p>
+          <a:p>
+            <a:r>
+              <a:t>DuckDB. My questions are like this:</a:t>
+            </a:r>
+          </a:p>
+          <a:p>
+            <a:r>
+              <a:t>which company receives the most requests?</a:t>
+            </a:r>
+          </a:p>
+          <a:p>
+            <a:r>
+              <a:t>That is what this database is built for. One file. No server.</a:t>
+            </a:r>
+          </a:p>
+          <a:p>
+            <a:r>
+              <a:t>And dnslib, instead of a configuration file.</a:t>
+            </a:r>
+          </a:p>
+          <a:p>
+            <a:r>
+              <a:t>I want my blocking logic to be code I can read and test.</a:t>
+            </a:r>
+          </a:p>
+          <a:p>
+            <a:r>
+              <a:t>On standards: every list I use is public.</a:t>
+            </a:r>
+          </a:p>
+          <a:p>
+            <a:r>
+              <a:t>So you can check any claim I make.</a:t>
+            </a:r>
+          </a:p>
+          <a:p>
+            <a:r>
+              <a:t>That is on purpose.</a:t>
             </a:r>
           </a:p>
           <a:p/>
           <a:p>
             <a:r>
-              <a:t>And dnslib rather than configuring dnsmasq, because I want the blocking logic to be</a:t>
-            </a:r>
-          </a:p>
-          <a:p>
-            <a:r>
-              <a:t>code I can read and test, not settings buried in a config file.</a:t>
-            </a:r>
-          </a:p>
-          <a:p/>
-          <a:p>
-            <a:r>
-              <a:t>On standards: everything I classify comes from a public list. That means a marker</a:t>
-            </a:r>
-          </a:p>
-          <a:p>
-            <a:r>
-              <a:t>can check any claim I make. That's deliberate.</a:t>
+              <a:t>[Delivery] Keep this slide fast. It is supporting detail, not the main point.</a:t>
             </a:r>
           </a:p>
         </p:txBody>

</xml_diff>